<commit_message>
Adiciona imagens de apoio geradas por IA ao deck de fisiopatologia hematológica
Co-authored-by: arena-agent <297053741+arena-agent@users.noreply.github.com>
</commit_message>
<xml_diff>
--- a/estudo-fisiopatologia-hematologica/fisiopatologia_hematologica.pptx
+++ b/estudo-fisiopatologia-hematologica/fisiopatologia_hematologica.pptx
@@ -9886,7 +9886,7 @@
         <p:spPr>
           <a:xfrm>
             <a:off x="594360" y="1417320"/>
-            <a:ext cx="10972800" cy="1325880"/>
+            <a:ext cx="6949440" cy="1325880"/>
           </a:xfrm>
           <a:prstGeom prst="roundRect">
             <a:avLst>
@@ -10066,7 +10066,7 @@
         <p:spPr>
           <a:xfrm>
             <a:off x="868680" y="1810512"/>
-            <a:ext cx="10515600" cy="868680"/>
+            <a:ext cx="6492240" cy="868680"/>
           </a:xfrm>
           <a:prstGeom prst="rect">
             <a:avLst/>
@@ -10108,7 +10108,7 @@
         <p:spPr>
           <a:xfrm>
             <a:off x="594360" y="2880360"/>
-            <a:ext cx="10972800" cy="777240"/>
+            <a:ext cx="6949440" cy="777240"/>
           </a:xfrm>
           <a:prstGeom prst="roundRect">
             <a:avLst>
@@ -10156,7 +10156,7 @@
         <p:spPr>
           <a:xfrm>
             <a:off x="777240" y="2990088"/>
-            <a:ext cx="10607040" cy="594360"/>
+            <a:ext cx="6583679" cy="594360"/>
           </a:xfrm>
           <a:prstGeom prst="rect">
             <a:avLst/>
@@ -10198,7 +10198,7 @@
         <p:spPr>
           <a:xfrm>
             <a:off x="594360" y="3794760"/>
-            <a:ext cx="3523488" cy="2240279"/>
+            <a:ext cx="2182367" cy="2240279"/>
           </a:xfrm>
           <a:prstGeom prst="roundRect">
             <a:avLst>
@@ -10246,7 +10246,7 @@
         <p:spPr>
           <a:xfrm>
             <a:off x="594360" y="3794760"/>
-            <a:ext cx="3523488" cy="45720"/>
+            <a:ext cx="2182367" cy="45720"/>
           </a:xfrm>
           <a:prstGeom prst="rect">
             <a:avLst/>
@@ -10290,7 +10290,7 @@
         <p:spPr>
           <a:xfrm>
             <a:off x="777240" y="3959352"/>
-            <a:ext cx="3157728" cy="1965959"/>
+            <a:ext cx="1816607" cy="1965959"/>
           </a:xfrm>
           <a:prstGeom prst="rect">
             <a:avLst/>
@@ -10356,8 +10356,8 @@
         </p:nvSpPr>
         <p:spPr>
           <a:xfrm>
-            <a:off x="4319016" y="3794760"/>
-            <a:ext cx="3523488" cy="2240279"/>
+            <a:off x="2977895" y="3794760"/>
+            <a:ext cx="2182367" cy="2240279"/>
           </a:xfrm>
           <a:prstGeom prst="roundRect">
             <a:avLst>
@@ -10404,8 +10404,8 @@
         </p:nvSpPr>
         <p:spPr>
           <a:xfrm>
-            <a:off x="4319016" y="3794760"/>
-            <a:ext cx="3523488" cy="45720"/>
+            <a:off x="2977895" y="3794760"/>
+            <a:ext cx="2182367" cy="45720"/>
           </a:xfrm>
           <a:prstGeom prst="rect">
             <a:avLst/>
@@ -10448,8 +10448,8 @@
         </p:nvSpPr>
         <p:spPr>
           <a:xfrm>
-            <a:off x="4501896" y="3959352"/>
-            <a:ext cx="3157728" cy="1965959"/>
+            <a:off x="3160776" y="3959352"/>
+            <a:ext cx="1816607" cy="1965959"/>
           </a:xfrm>
           <a:prstGeom prst="rect">
             <a:avLst/>
@@ -10515,8 +10515,8 @@
         </p:nvSpPr>
         <p:spPr>
           <a:xfrm>
-            <a:off x="8043672" y="3794760"/>
-            <a:ext cx="3523488" cy="2240279"/>
+            <a:off x="5361432" y="3794760"/>
+            <a:ext cx="2182367" cy="2240279"/>
           </a:xfrm>
           <a:prstGeom prst="roundRect">
             <a:avLst>
@@ -10563,8 +10563,8 @@
         </p:nvSpPr>
         <p:spPr>
           <a:xfrm>
-            <a:off x="8043672" y="3794760"/>
-            <a:ext cx="3523488" cy="45720"/>
+            <a:off x="5361432" y="3794760"/>
+            <a:ext cx="2182367" cy="45720"/>
           </a:xfrm>
           <a:prstGeom prst="rect">
             <a:avLst/>
@@ -10607,8 +10607,8 @@
         </p:nvSpPr>
         <p:spPr>
           <a:xfrm>
-            <a:off x="8226551" y="3959352"/>
-            <a:ext cx="3157728" cy="1965959"/>
+            <a:off x="5544312" y="3959352"/>
+            <a:ext cx="1816607" cy="1965959"/>
           </a:xfrm>
           <a:prstGeom prst="rect">
             <a:avLst/>
@@ -10662,6 +10662,120 @@
                 <a:latin typeface="Montserrat"/>
               </a:rPr>
               <a:t>Com hemoglobina abaixo de 100 g/L, o débito sobe; hipóxia miocárdica causa angina.</a:t>
+            </a:r>
+          </a:p>
+        </p:txBody>
+      </p:sp>
+      <p:sp>
+        <p:nvSpPr>
+          <p:cNvPr id="24" name="Rounded Rectangle 23"/>
+          <p:cNvSpPr/>
+          <p:nvPr/>
+        </p:nvSpPr>
+        <p:spPr>
+          <a:xfrm>
+            <a:off x="7690104" y="2619340"/>
+            <a:ext cx="3913632" cy="2167959"/>
+          </a:xfrm>
+          <a:prstGeom prst="roundRect">
+            <a:avLst>
+              <a:gd name="adj" fmla="val 2000"/>
+            </a:avLst>
+          </a:prstGeom>
+          <a:solidFill>
+            <a:srgbClr val="FFFFFF"/>
+          </a:solidFill>
+          <a:ln w="9525">
+            <a:solidFill>
+              <a:srgbClr val="D9DDF2"/>
+            </a:solidFill>
+          </a:ln>
+          <a:effectLst/>
+        </p:spPr>
+        <p:style>
+          <a:lnRef idx="1">
+            <a:schemeClr val="accent1"/>
+          </a:lnRef>
+          <a:fillRef idx="3">
+            <a:schemeClr val="accent1"/>
+          </a:fillRef>
+          <a:effectRef idx="2">
+            <a:schemeClr val="accent1"/>
+          </a:effectRef>
+          <a:fontRef idx="minor">
+            <a:schemeClr val="lt1"/>
+          </a:fontRef>
+        </p:style>
+        <p:txBody>
+          <a:bodyPr rtlCol="0" anchor="ctr"/>
+          <a:lstStyle/>
+          <a:p>
+            <a:pPr algn="ctr"/>
+          </a:p>
+        </p:txBody>
+      </p:sp>
+      <p:pic>
+        <p:nvPicPr>
+          <p:cNvPr id="25" name="Picture 24" descr="curva_hemoglobina_v2.png"/>
+          <p:cNvPicPr>
+            <a:picLocks noChangeAspect="1"/>
+          </p:cNvPicPr>
+          <p:nvPr/>
+        </p:nvPicPr>
+        <p:blipFill>
+          <a:blip r:embed="rId2"/>
+          <a:stretch>
+            <a:fillRect/>
+          </a:stretch>
+        </p:blipFill>
+        <p:spPr>
+          <a:xfrm>
+            <a:off x="7726679" y="2655916"/>
+            <a:ext cx="3840480" cy="2094807"/>
+          </a:xfrm>
+          <a:prstGeom prst="rect">
+            <a:avLst/>
+          </a:prstGeom>
+        </p:spPr>
+      </p:pic>
+      <p:sp>
+        <p:nvSpPr>
+          <p:cNvPr id="26" name="TextBox 25"/>
+          <p:cNvSpPr txBox="1"/>
+          <p:nvPr/>
+        </p:nvSpPr>
+        <p:spPr>
+          <a:xfrm>
+            <a:off x="594360" y="6053328"/>
+            <a:ext cx="10972800" cy="256032"/>
+          </a:xfrm>
+          <a:prstGeom prst="rect">
+            <a:avLst/>
+          </a:prstGeom>
+          <a:noFill/>
+        </p:spPr>
+        <p:txBody>
+          <a:bodyPr wrap="square" anchor="t" lIns="0" rIns="0" tIns="0" bIns="0">
+            <a:spAutoFit/>
+          </a:bodyPr>
+          <a:lstStyle/>
+          <a:p>
+            <a:pPr algn="l">
+              <a:lnSpc>
+                <a:spcPct val="108000"/>
+              </a:lnSpc>
+              <a:spcAft>
+                <a:spcPts val="300"/>
+              </a:spcAft>
+            </a:pPr>
+            <a:r>
+              <a:rPr sz="900" b="0" i="1">
+                <a:solidFill>
+                  <a:srgbClr val="606383"/>
+                </a:solidFill>
+                <a:latin typeface="Montserrat"/>
+              </a:rPr>
+              <a:t>Fonte / Crédito: Gráfico esquemático gerado por IA, apoio visual</a:t>
             </a:r>
           </a:p>
         </p:txBody>
@@ -14426,7 +14540,7 @@
         <p:spPr>
           <a:xfrm>
             <a:off x="594360" y="1417320"/>
-            <a:ext cx="5349240" cy="1965960"/>
+            <a:ext cx="4206240" cy="1965960"/>
           </a:xfrm>
           <a:prstGeom prst="roundRect">
             <a:avLst>
@@ -14472,7 +14586,7 @@
         <p:spPr>
           <a:xfrm>
             <a:off x="777240" y="1554480"/>
-            <a:ext cx="4983479" cy="228600"/>
+            <a:ext cx="3840479" cy="228600"/>
           </a:xfrm>
           <a:prstGeom prst="rect">
             <a:avLst/>
@@ -14514,7 +14628,7 @@
         <p:spPr>
           <a:xfrm>
             <a:off x="777240" y="1810512"/>
-            <a:ext cx="4983479" cy="1463040"/>
+            <a:ext cx="3840479" cy="1463040"/>
           </a:xfrm>
           <a:prstGeom prst="rect">
             <a:avLst/>
@@ -14556,7 +14670,7 @@
         <p:spPr>
           <a:xfrm>
             <a:off x="594360" y="3520440"/>
-            <a:ext cx="5349240" cy="2423160"/>
+            <a:ext cx="4206240" cy="2423160"/>
           </a:xfrm>
           <a:prstGeom prst="roundRect">
             <a:avLst>
@@ -14604,7 +14718,7 @@
         <p:spPr>
           <a:xfrm>
             <a:off x="777240" y="3657600"/>
-            <a:ext cx="4983479" cy="2194560"/>
+            <a:ext cx="3840479" cy="2194560"/>
           </a:xfrm>
           <a:prstGeom prst="rect">
             <a:avLst/>
@@ -14651,7 +14765,7 @@
               </a:spcAft>
             </a:pPr>
             <a:r>
-              <a:rPr sz="1100" b="0" i="0">
+              <a:rPr sz="1050" b="0" i="0">
                 <a:solidFill>
                   <a:srgbClr val="2B2C4A"/>
                 </a:solidFill>
@@ -14673,7 +14787,7 @@
               </a:spcAft>
             </a:pPr>
             <a:r>
-              <a:rPr sz="1100" b="0" i="0">
+              <a:rPr sz="1050" b="0" i="0">
                 <a:solidFill>
                   <a:srgbClr val="2B2C4A"/>
                 </a:solidFill>
@@ -14695,7 +14809,7 @@
               </a:spcAft>
             </a:pPr>
             <a:r>
-              <a:rPr sz="1100" b="0" i="0">
+              <a:rPr sz="1050" b="0" i="0">
                 <a:solidFill>
                   <a:srgbClr val="2B2C4A"/>
                 </a:solidFill>
@@ -14714,8 +14828,8 @@
         </p:nvSpPr>
         <p:spPr>
           <a:xfrm>
-            <a:off x="6172200" y="1417320"/>
-            <a:ext cx="5394960" cy="1965960"/>
+            <a:off x="4983480" y="1417320"/>
+            <a:ext cx="4206240" cy="1965960"/>
           </a:xfrm>
           <a:prstGeom prst="roundRect">
             <a:avLst>
@@ -14762,8 +14876,8 @@
         </p:nvSpPr>
         <p:spPr>
           <a:xfrm>
-            <a:off x="6400800" y="1554480"/>
-            <a:ext cx="4937760" cy="1737360"/>
+            <a:off x="5212080" y="1554480"/>
+            <a:ext cx="3749039" cy="1737360"/>
           </a:xfrm>
           <a:prstGeom prst="rect">
             <a:avLst/>
@@ -14829,8 +14943,8 @@
         </p:nvSpPr>
         <p:spPr>
           <a:xfrm>
-            <a:off x="6172200" y="3520440"/>
-            <a:ext cx="5394960" cy="1051560"/>
+            <a:off x="4983480" y="3520440"/>
+            <a:ext cx="4206240" cy="1051560"/>
           </a:xfrm>
           <a:prstGeom prst="roundRect">
             <a:avLst>
@@ -14877,8 +14991,8 @@
         </p:nvSpPr>
         <p:spPr>
           <a:xfrm>
-            <a:off x="6400800" y="3611880"/>
-            <a:ext cx="4937760" cy="868680"/>
+            <a:off x="5212080" y="3611880"/>
+            <a:ext cx="3749039" cy="868680"/>
           </a:xfrm>
           <a:prstGeom prst="rect">
             <a:avLst/>
@@ -14944,8 +15058,8 @@
         </p:nvSpPr>
         <p:spPr>
           <a:xfrm>
-            <a:off x="6172200" y="4709160"/>
-            <a:ext cx="5394960" cy="1234440"/>
+            <a:off x="4983480" y="4709160"/>
+            <a:ext cx="4206240" cy="1234440"/>
           </a:xfrm>
           <a:prstGeom prst="roundRect">
             <a:avLst>
@@ -14990,8 +15104,8 @@
         </p:nvSpPr>
         <p:spPr>
           <a:xfrm>
-            <a:off x="6400800" y="4800600"/>
-            <a:ext cx="4937760" cy="1051560"/>
+            <a:off x="5212080" y="4800600"/>
+            <a:ext cx="3749039" cy="1051560"/>
           </a:xfrm>
           <a:prstGeom prst="rect">
             <a:avLst/>
@@ -15045,6 +15159,120 @@
                 <a:latin typeface="Montserrat"/>
               </a:rPr>
               <a:t>A esplenectomia remove o principal sítio de destruição; a infecção por parvovírus B19 pode causar crise aplásica.</a:t>
+            </a:r>
+          </a:p>
+        </p:txBody>
+      </p:sp>
+      <p:sp>
+        <p:nvSpPr>
+          <p:cNvPr id="19" name="Rounded Rectangle 18"/>
+          <p:cNvSpPr/>
+          <p:nvPr/>
+        </p:nvSpPr>
+        <p:spPr>
+          <a:xfrm>
+            <a:off x="9336024" y="3045367"/>
+            <a:ext cx="2267712" cy="1270184"/>
+          </a:xfrm>
+          <a:prstGeom prst="roundRect">
+            <a:avLst>
+              <a:gd name="adj" fmla="val 2000"/>
+            </a:avLst>
+          </a:prstGeom>
+          <a:solidFill>
+            <a:srgbClr val="FFFFFF"/>
+          </a:solidFill>
+          <a:ln w="9525">
+            <a:solidFill>
+              <a:srgbClr val="D9DDF2"/>
+            </a:solidFill>
+          </a:ln>
+          <a:effectLst/>
+        </p:spPr>
+        <p:style>
+          <a:lnRef idx="1">
+            <a:schemeClr val="accent1"/>
+          </a:lnRef>
+          <a:fillRef idx="3">
+            <a:schemeClr val="accent1"/>
+          </a:fillRef>
+          <a:effectRef idx="2">
+            <a:schemeClr val="accent1"/>
+          </a:effectRef>
+          <a:fontRef idx="minor">
+            <a:schemeClr val="lt1"/>
+          </a:fontRef>
+        </p:style>
+        <p:txBody>
+          <a:bodyPr rtlCol="0" anchor="ctr"/>
+          <a:lstStyle/>
+          <a:p>
+            <a:pPr algn="ctr"/>
+          </a:p>
+        </p:txBody>
+      </p:sp>
+      <p:pic>
+        <p:nvPicPr>
+          <p:cNvPr id="20" name="Picture 19" descr="esferocito_vs_disco_v2.png"/>
+          <p:cNvPicPr>
+            <a:picLocks noChangeAspect="1"/>
+          </p:cNvPicPr>
+          <p:nvPr/>
+        </p:nvPicPr>
+        <p:blipFill>
+          <a:blip r:embed="rId2"/>
+          <a:stretch>
+            <a:fillRect/>
+          </a:stretch>
+        </p:blipFill>
+        <p:spPr>
+          <a:xfrm>
+            <a:off x="9372600" y="3081943"/>
+            <a:ext cx="2194560" cy="1197032"/>
+          </a:xfrm>
+          <a:prstGeom prst="rect">
+            <a:avLst/>
+          </a:prstGeom>
+        </p:spPr>
+      </p:pic>
+      <p:sp>
+        <p:nvSpPr>
+          <p:cNvPr id="21" name="TextBox 20"/>
+          <p:cNvSpPr txBox="1"/>
+          <p:nvPr/>
+        </p:nvSpPr>
+        <p:spPr>
+          <a:xfrm>
+            <a:off x="594360" y="6053328"/>
+            <a:ext cx="10972800" cy="256032"/>
+          </a:xfrm>
+          <a:prstGeom prst="rect">
+            <a:avLst/>
+          </a:prstGeom>
+          <a:noFill/>
+        </p:spPr>
+        <p:txBody>
+          <a:bodyPr wrap="square" anchor="t" lIns="0" rIns="0" tIns="0" bIns="0">
+            <a:spAutoFit/>
+          </a:bodyPr>
+          <a:lstStyle/>
+          <a:p>
+            <a:pPr algn="l">
+              <a:lnSpc>
+                <a:spcPct val="108000"/>
+              </a:lnSpc>
+              <a:spcAft>
+                <a:spcPts val="300"/>
+              </a:spcAft>
+            </a:pPr>
+            <a:r>
+              <a:rPr sz="900" b="0" i="1">
+                <a:solidFill>
+                  <a:srgbClr val="606383"/>
+                </a:solidFill>
+                <a:latin typeface="Montserrat"/>
+              </a:rPr>
+              <a:t>Fonte / Crédito: Ilustração esquemática gerada por IA, apoio visual</a:t>
             </a:r>
           </a:p>
         </p:txBody>
@@ -20673,7 +20901,7 @@
         <p:spPr>
           <a:xfrm>
             <a:off x="594360" y="1417320"/>
-            <a:ext cx="10972800" cy="1325880"/>
+            <a:ext cx="6949440" cy="1325880"/>
           </a:xfrm>
           <a:prstGeom prst="roundRect">
             <a:avLst>
@@ -20853,7 +21081,7 @@
         <p:spPr>
           <a:xfrm>
             <a:off x="868680" y="1810512"/>
-            <a:ext cx="10515600" cy="868680"/>
+            <a:ext cx="6492240" cy="868680"/>
           </a:xfrm>
           <a:prstGeom prst="rect">
             <a:avLst/>
@@ -20895,7 +21123,7 @@
         <p:spPr>
           <a:xfrm>
             <a:off x="594360" y="2880360"/>
-            <a:ext cx="10972800" cy="777240"/>
+            <a:ext cx="6949440" cy="777240"/>
           </a:xfrm>
           <a:prstGeom prst="roundRect">
             <a:avLst>
@@ -20943,7 +21171,7 @@
         <p:spPr>
           <a:xfrm>
             <a:off x="777240" y="2990088"/>
-            <a:ext cx="10607040" cy="594360"/>
+            <a:ext cx="6583679" cy="594360"/>
           </a:xfrm>
           <a:prstGeom prst="rect">
             <a:avLst/>
@@ -20985,7 +21213,7 @@
         <p:spPr>
           <a:xfrm>
             <a:off x="594360" y="3794760"/>
-            <a:ext cx="5385816" cy="2240279"/>
+            <a:ext cx="3374136" cy="2240279"/>
           </a:xfrm>
           <a:prstGeom prst="roundRect">
             <a:avLst>
@@ -21033,7 +21261,7 @@
         <p:spPr>
           <a:xfrm>
             <a:off x="594360" y="3794760"/>
-            <a:ext cx="5385816" cy="45720"/>
+            <a:ext cx="3374136" cy="45720"/>
           </a:xfrm>
           <a:prstGeom prst="rect">
             <a:avLst/>
@@ -21077,7 +21305,7 @@
         <p:spPr>
           <a:xfrm>
             <a:off x="777240" y="3959352"/>
-            <a:ext cx="5020055" cy="1965959"/>
+            <a:ext cx="3008376" cy="1965959"/>
           </a:xfrm>
           <a:prstGeom prst="rect">
             <a:avLst/>
@@ -21143,8 +21371,8 @@
         </p:nvSpPr>
         <p:spPr>
           <a:xfrm>
-            <a:off x="6181344" y="3794760"/>
-            <a:ext cx="5385816" cy="2240279"/>
+            <a:off x="4169664" y="3794760"/>
+            <a:ext cx="3374136" cy="2240279"/>
           </a:xfrm>
           <a:prstGeom prst="roundRect">
             <a:avLst>
@@ -21191,8 +21419,8 @@
         </p:nvSpPr>
         <p:spPr>
           <a:xfrm>
-            <a:off x="6181344" y="3794760"/>
-            <a:ext cx="5385816" cy="45720"/>
+            <a:off x="4169664" y="3794760"/>
+            <a:ext cx="3374136" cy="45720"/>
           </a:xfrm>
           <a:prstGeom prst="rect">
             <a:avLst/>
@@ -21235,8 +21463,8 @@
         </p:nvSpPr>
         <p:spPr>
           <a:xfrm>
-            <a:off x="6364224" y="3959352"/>
-            <a:ext cx="5020055" cy="1965959"/>
+            <a:off x="4352544" y="3959352"/>
+            <a:ext cx="3008376" cy="1965959"/>
           </a:xfrm>
           <a:prstGeom prst="rect">
             <a:avLst/>
@@ -21290,6 +21518,120 @@
                 <a:latin typeface="Montserrat"/>
               </a:rPr>
               <a:t>Mecanismos imunes ou agressão mecânica microvascular consomem plaquetas além da reposição.</a:t>
+            </a:r>
+          </a:p>
+        </p:txBody>
+      </p:sp>
+      <p:sp>
+        <p:nvSpPr>
+          <p:cNvPr id="21" name="Rounded Rectangle 20"/>
+          <p:cNvSpPr/>
+          <p:nvPr/>
+        </p:nvSpPr>
+        <p:spPr>
+          <a:xfrm>
+            <a:off x="7690104" y="2619340"/>
+            <a:ext cx="3913632" cy="2167959"/>
+          </a:xfrm>
+          <a:prstGeom prst="roundRect">
+            <a:avLst>
+              <a:gd name="adj" fmla="val 2000"/>
+            </a:avLst>
+          </a:prstGeom>
+          <a:solidFill>
+            <a:srgbClr val="FFFFFF"/>
+          </a:solidFill>
+          <a:ln w="9525">
+            <a:solidFill>
+              <a:srgbClr val="D9DDF2"/>
+            </a:solidFill>
+          </a:ln>
+          <a:effectLst/>
+        </p:spPr>
+        <p:style>
+          <a:lnRef idx="1">
+            <a:schemeClr val="accent1"/>
+          </a:lnRef>
+          <a:fillRef idx="3">
+            <a:schemeClr val="accent1"/>
+          </a:fillRef>
+          <a:effectRef idx="2">
+            <a:schemeClr val="accent1"/>
+          </a:effectRef>
+          <a:fontRef idx="minor">
+            <a:schemeClr val="lt1"/>
+          </a:fontRef>
+        </p:style>
+        <p:txBody>
+          <a:bodyPr rtlCol="0" anchor="ctr"/>
+          <a:lstStyle/>
+          <a:p>
+            <a:pPr algn="ctr"/>
+          </a:p>
+        </p:txBody>
+      </p:sp>
+      <p:pic>
+        <p:nvPicPr>
+          <p:cNvPr id="22" name="Picture 21" descr="trombocitopenia_vias_v2.png"/>
+          <p:cNvPicPr>
+            <a:picLocks noChangeAspect="1"/>
+          </p:cNvPicPr>
+          <p:nvPr/>
+        </p:nvPicPr>
+        <p:blipFill>
+          <a:blip r:embed="rId2"/>
+          <a:stretch>
+            <a:fillRect/>
+          </a:stretch>
+        </p:blipFill>
+        <p:spPr>
+          <a:xfrm>
+            <a:off x="7726679" y="2655916"/>
+            <a:ext cx="3840480" cy="2094807"/>
+          </a:xfrm>
+          <a:prstGeom prst="rect">
+            <a:avLst/>
+          </a:prstGeom>
+        </p:spPr>
+      </p:pic>
+      <p:sp>
+        <p:nvSpPr>
+          <p:cNvPr id="23" name="TextBox 22"/>
+          <p:cNvSpPr txBox="1"/>
+          <p:nvPr/>
+        </p:nvSpPr>
+        <p:spPr>
+          <a:xfrm>
+            <a:off x="594360" y="6053328"/>
+            <a:ext cx="10972800" cy="256032"/>
+          </a:xfrm>
+          <a:prstGeom prst="rect">
+            <a:avLst/>
+          </a:prstGeom>
+          <a:noFill/>
+        </p:spPr>
+        <p:txBody>
+          <a:bodyPr wrap="square" anchor="t" lIns="0" rIns="0" tIns="0" bIns="0">
+            <a:spAutoFit/>
+          </a:bodyPr>
+          <a:lstStyle/>
+          <a:p>
+            <a:pPr algn="l">
+              <a:lnSpc>
+                <a:spcPct val="108000"/>
+              </a:lnSpc>
+              <a:spcAft>
+                <a:spcPts val="300"/>
+              </a:spcAft>
+            </a:pPr>
+            <a:r>
+              <a:rPr sz="900" b="0" i="1">
+                <a:solidFill>
+                  <a:srgbClr val="606383"/>
+                </a:solidFill>
+                <a:latin typeface="Montserrat"/>
+              </a:rPr>
+              <a:t>Fonte / Crédito: Ilustração esquemática gerada por IA, apoio visual</a:t>
             </a:r>
           </a:p>
         </p:txBody>
@@ -24387,8 +24729,8 @@
         </p:nvSpPr>
         <p:spPr>
           <a:xfrm>
-            <a:off x="4892040" y="1417320"/>
-            <a:ext cx="6675120" cy="2171700"/>
+            <a:off x="3886200" y="1417320"/>
+            <a:ext cx="3291840" cy="2171700"/>
           </a:xfrm>
           <a:prstGeom prst="roundRect">
             <a:avLst>
@@ -24435,7 +24777,7 @@
         </p:nvSpPr>
         <p:spPr>
           <a:xfrm>
-            <a:off x="4892040" y="1417320"/>
+            <a:off x="3886200" y="1417320"/>
             <a:ext cx="54864" cy="2171700"/>
           </a:xfrm>
           <a:prstGeom prst="rect">
@@ -24479,8 +24821,8 @@
         </p:nvSpPr>
         <p:spPr>
           <a:xfrm>
-            <a:off x="5120640" y="1527048"/>
-            <a:ext cx="6263640" cy="1952243"/>
+            <a:off x="4114800" y="1527048"/>
+            <a:ext cx="2880360" cy="1952243"/>
           </a:xfrm>
           <a:prstGeom prst="rect">
             <a:avLst/>
@@ -24546,8 +24888,8 @@
         </p:nvSpPr>
         <p:spPr>
           <a:xfrm>
-            <a:off x="4892040" y="3771900"/>
-            <a:ext cx="6675120" cy="2171700"/>
+            <a:off x="3886200" y="3771900"/>
+            <a:ext cx="3291840" cy="2171700"/>
           </a:xfrm>
           <a:prstGeom prst="roundRect">
             <a:avLst>
@@ -24594,7 +24936,7 @@
         </p:nvSpPr>
         <p:spPr>
           <a:xfrm>
-            <a:off x="4892040" y="3771900"/>
+            <a:off x="3886200" y="3771900"/>
             <a:ext cx="54864" cy="2171700"/>
           </a:xfrm>
           <a:prstGeom prst="rect">
@@ -24638,8 +24980,8 @@
         </p:nvSpPr>
         <p:spPr>
           <a:xfrm>
-            <a:off x="5120640" y="3881628"/>
-            <a:ext cx="6263640" cy="1952243"/>
+            <a:off x="4114800" y="3881628"/>
+            <a:ext cx="2880360" cy="1952243"/>
           </a:xfrm>
           <a:prstGeom prst="rect">
             <a:avLst/>
@@ -24693,6 +25035,120 @@
                 <a:latin typeface="Montserrat"/>
               </a:rPr>
               <a:t>A contagem cai, mas a medula continua produzindo. O problema está na distribuição.</a:t>
+            </a:r>
+          </a:p>
+        </p:txBody>
+      </p:sp>
+      <p:sp>
+        <p:nvSpPr>
+          <p:cNvPr id="19" name="Rounded Rectangle 18"/>
+          <p:cNvSpPr/>
+          <p:nvPr/>
+        </p:nvSpPr>
+        <p:spPr>
+          <a:xfrm>
+            <a:off x="7324344" y="2496727"/>
+            <a:ext cx="4279392" cy="2367464"/>
+          </a:xfrm>
+          <a:prstGeom prst="roundRect">
+            <a:avLst>
+              <a:gd name="adj" fmla="val 2000"/>
+            </a:avLst>
+          </a:prstGeom>
+          <a:solidFill>
+            <a:srgbClr val="FFFFFF"/>
+          </a:solidFill>
+          <a:ln w="9525">
+            <a:solidFill>
+              <a:srgbClr val="D9DDF2"/>
+            </a:solidFill>
+          </a:ln>
+          <a:effectLst/>
+        </p:spPr>
+        <p:style>
+          <a:lnRef idx="1">
+            <a:schemeClr val="accent1"/>
+          </a:lnRef>
+          <a:fillRef idx="3">
+            <a:schemeClr val="accent1"/>
+          </a:fillRef>
+          <a:effectRef idx="2">
+            <a:schemeClr val="accent1"/>
+          </a:effectRef>
+          <a:fontRef idx="minor">
+            <a:schemeClr val="lt1"/>
+          </a:fontRef>
+        </p:style>
+        <p:txBody>
+          <a:bodyPr rtlCol="0" anchor="ctr"/>
+          <a:lstStyle/>
+          <a:p>
+            <a:pPr algn="ctr"/>
+          </a:p>
+        </p:txBody>
+      </p:sp>
+      <p:pic>
+        <p:nvPicPr>
+          <p:cNvPr id="20" name="Picture 19" descr="baco_sequestro.png"/>
+          <p:cNvPicPr>
+            <a:picLocks noChangeAspect="1"/>
+          </p:cNvPicPr>
+          <p:nvPr/>
+        </p:nvPicPr>
+        <p:blipFill>
+          <a:blip r:embed="rId2"/>
+          <a:stretch>
+            <a:fillRect/>
+          </a:stretch>
+        </p:blipFill>
+        <p:spPr>
+          <a:xfrm>
+            <a:off x="7360920" y="2533303"/>
+            <a:ext cx="4206240" cy="2294312"/>
+          </a:xfrm>
+          <a:prstGeom prst="rect">
+            <a:avLst/>
+          </a:prstGeom>
+        </p:spPr>
+      </p:pic>
+      <p:sp>
+        <p:nvSpPr>
+          <p:cNvPr id="21" name="TextBox 20"/>
+          <p:cNvSpPr txBox="1"/>
+          <p:nvPr/>
+        </p:nvSpPr>
+        <p:spPr>
+          <a:xfrm>
+            <a:off x="594360" y="6053328"/>
+            <a:ext cx="10972800" cy="256032"/>
+          </a:xfrm>
+          <a:prstGeom prst="rect">
+            <a:avLst/>
+          </a:prstGeom>
+          <a:noFill/>
+        </p:spPr>
+        <p:txBody>
+          <a:bodyPr wrap="square" anchor="t" lIns="0" rIns="0" tIns="0" bIns="0">
+            <a:spAutoFit/>
+          </a:bodyPr>
+          <a:lstStyle/>
+          <a:p>
+            <a:pPr algn="l">
+              <a:lnSpc>
+                <a:spcPct val="108000"/>
+              </a:lnSpc>
+              <a:spcAft>
+                <a:spcPts val="300"/>
+              </a:spcAft>
+            </a:pPr>
+            <a:r>
+              <a:rPr sz="900" b="0" i="1">
+                <a:solidFill>
+                  <a:srgbClr val="606383"/>
+                </a:solidFill>
+                <a:latin typeface="Montserrat"/>
+              </a:rPr>
+              <a:t>Fonte / Crédito: Ilustração esquemática gerada por IA, apoio visual</a:t>
             </a:r>
           </a:p>
         </p:txBody>

</xml_diff>